<commit_message>
docs: Agent1 - sync paper & PPT with canonical real data (2026-06-10 audit)
Key changes:
- Abstract: fix prosody direction error (-2pp -> +9.73pp SA>>PG on adults)
- E1 table: replace simulated values with real 3-seed (C-BESD/FAU) and 2-seed (IEMOCAP) data
- E3: full 6-direction zero-shot matrix with real WA/UAR
- E4: C-BESD rows updated with v5 Run 2 real data
- E5/E6/E7: clearly marked [待B1实验验证] with preliminary v5 data where available
- Analysis: Finding 1-4 updated with canonical FD/APC/layer weights/prosody gap
- PPT: fix Slide 11 Exp4 mislabel (Exp4=zero-shot FAU, not IEMOCAP SA), update SA 68.02%->75.96%
- PPT regenerated: 17 slides
- task_plan.md + progress.md created
</commit_message>
<xml_diff>
--- a/paper_draft/儿童SER_项目汇报_v3.pptx
+++ b/paper_draft/儿童SER_项目汇报_v3.pptx
@@ -5178,7 +5178,7 @@
               </a:defRPr>
             </a:pPr>
             <a:r>
-              <a:t>05  主实验结果：6组AC Suite + 池化对比</a:t>
+              <a:t>05  主实验结果：IEMOCAP双池化对比 (真实数据)</a:t>
             </a:r>
           </a:p>
         </p:txBody>
@@ -5213,7 +5213,7 @@
               </a:defRPr>
             </a:pPr>
             <a:r>
-              <a:t>AC Suite 2026-05 协议 | 以下数值为模拟估计 [待实验验证]</a:t>
+              <a:t>AC Suite 2026-05 | IEMOCAP 2-seed: SA=75.96%±7.94% vs PG=66.23%±7.56% (Δ=+9.73pp) | C-BESD/FAU数据已更新</a:t>
             </a:r>
           </a:p>
         </p:txBody>
@@ -5253,30 +5253,239 @@
           </a:p>
         </p:txBody>
       </p:sp>
-      <p:pic>
-        <p:nvPicPr>
-          <p:cNvPr id="5" name="Picture 4" descr="fig01_main_results.png"/>
-          <p:cNvPicPr>
-            <a:picLocks noChangeAspect="1"/>
-          </p:cNvPicPr>
-          <p:nvPr/>
-        </p:nvPicPr>
-        <p:blipFill>
-          <a:blip r:embed="rId2"/>
-          <a:stretch>
-            <a:fillRect/>
-          </a:stretch>
-        </p:blipFill>
-        <p:spPr>
-          <a:xfrm>
-            <a:off x="182880" y="1005840"/>
-            <a:ext cx="8778240" cy="3474720"/>
-          </a:xfrm>
-          <a:prstGeom prst="rect">
-            <a:avLst/>
-          </a:prstGeom>
-        </p:spPr>
-      </p:pic>
+      <p:sp>
+        <p:nvSpPr>
+          <p:cNvPr id="5" name="TextBox 4"/>
+          <p:cNvSpPr txBox="1"/>
+          <p:nvPr/>
+        </p:nvSpPr>
+        <p:spPr>
+          <a:xfrm>
+            <a:off x="457200" y="1097280"/>
+            <a:ext cx="8229600" cy="2286000"/>
+          </a:xfrm>
+          <a:prstGeom prst="rect">
+            <a:avLst/>
+          </a:prstGeom>
+          <a:noFill/>
+        </p:spPr>
+        <p:txBody>
+          <a:bodyPr wrap="square">
+            <a:spAutoFit/>
+          </a:bodyPr>
+          <a:lstStyle/>
+          <a:p>
+            <a:pPr>
+              <a:spcAft>
+                <a:spcPts val="300"/>
+              </a:spcAft>
+              <a:defRPr sz="1100">
+                <a:solidFill>
+                  <a:srgbClr val="2D2D2D"/>
+                </a:solidFill>
+              </a:defRPr>
+            </a:pPr>
+            <a:r>
+              <a:t>IEMOCAP (成人, 4-class, 2-seed mean±std, s456 val=0不可用) — 真实实验数据:</a:t>
+            </a:r>
+          </a:p>
+          <a:p>
+            <a:pPr>
+              <a:spcAft>
+                <a:spcPts val="300"/>
+              </a:spcAft>
+              <a:defRPr sz="1100">
+                <a:solidFill>
+                  <a:srgbClr val="2D2D2D"/>
+                </a:solidFill>
+              </a:defRPr>
+            </a:pPr>
+          </a:p>
+          <a:p>
+            <a:pPr>
+              <a:spcAft>
+                <a:spcPts val="300"/>
+              </a:spcAft>
+              <a:defRPr sz="1100">
+                <a:solidFill>
+                  <a:srgbClr val="2D2D2D"/>
+                </a:solidFill>
+              </a:defRPr>
+            </a:pPr>
+            <a:r>
+              <a:t>  Self-Attention Pooling:</a:t>
+            </a:r>
+          </a:p>
+          <a:p>
+            <a:pPr>
+              <a:spcAft>
+                <a:spcPts val="300"/>
+              </a:spcAft>
+              <a:defRPr sz="1100">
+                <a:solidFill>
+                  <a:srgbClr val="2D2D2D"/>
+                </a:solidFill>
+              </a:defRPr>
+            </a:pPr>
+            <a:r>
+              <a:t>    Test WA = 75.96% ± 7.94%  |  2-seed (42, 123)</a:t>
+            </a:r>
+          </a:p>
+          <a:p>
+            <a:pPr>
+              <a:spcAft>
+                <a:spcPts val="300"/>
+              </a:spcAft>
+              <a:defRPr sz="1100">
+                <a:solidFill>
+                  <a:srgbClr val="2D2D2D"/>
+                </a:solidFill>
+              </a:defRPr>
+            </a:pPr>
+          </a:p>
+          <a:p>
+            <a:pPr>
+              <a:spcAft>
+                <a:spcPts val="300"/>
+              </a:spcAft>
+              <a:defRPr sz="1100">
+                <a:solidFill>
+                  <a:srgbClr val="2D2D2D"/>
+                </a:solidFill>
+              </a:defRPr>
+            </a:pPr>
+            <a:r>
+              <a:t>  Prosody Guided Pooling:</a:t>
+            </a:r>
+          </a:p>
+          <a:p>
+            <a:pPr>
+              <a:spcAft>
+                <a:spcPts val="300"/>
+              </a:spcAft>
+              <a:defRPr sz="1100">
+                <a:solidFill>
+                  <a:srgbClr val="2D2D2D"/>
+                </a:solidFill>
+              </a:defRPr>
+            </a:pPr>
+            <a:r>
+              <a:t>    Test WA = 66.23% ± 7.56%  |  2-seed (42, 123)</a:t>
+            </a:r>
+          </a:p>
+          <a:p>
+            <a:pPr>
+              <a:spcAft>
+                <a:spcPts val="300"/>
+              </a:spcAft>
+              <a:defRPr sz="1100">
+                <a:solidFill>
+                  <a:srgbClr val="2D2D2D"/>
+                </a:solidFill>
+              </a:defRPr>
+            </a:pPr>
+          </a:p>
+          <a:p>
+            <a:pPr>
+              <a:spcAft>
+                <a:spcPts val="300"/>
+              </a:spcAft>
+              <a:defRPr sz="1100">
+                <a:solidFill>
+                  <a:srgbClr val="2D2D2D"/>
+                </a:solidFill>
+              </a:defRPr>
+            </a:pPr>
+            <a:r>
+              <a:t>  Δ(SA − PG) = +9.73pp  →  韵律先验在成人语音上有害</a:t>
+            </a:r>
+          </a:p>
+          <a:p>
+            <a:pPr>
+              <a:spcAft>
+                <a:spcPts val="300"/>
+              </a:spcAft>
+              <a:defRPr sz="1100">
+                <a:solidFill>
+                  <a:srgbClr val="2D2D2D"/>
+                </a:solidFill>
+              </a:defRPr>
+            </a:pPr>
+          </a:p>
+          <a:p>
+            <a:pPr>
+              <a:spcAft>
+                <a:spcPts val="300"/>
+              </a:spcAft>
+              <a:defRPr sz="1100">
+                <a:solidFill>
+                  <a:srgbClr val="2D2D2D"/>
+                </a:solidFill>
+              </a:defRPr>
+            </a:pPr>
+            <a:r>
+              <a:t>C-BESD (6-class, 3-seed):</a:t>
+            </a:r>
+          </a:p>
+          <a:p>
+            <a:pPr>
+              <a:spcAft>
+                <a:spcPts val="300"/>
+              </a:spcAft>
+              <a:defRPr sz="1100">
+                <a:solidFill>
+                  <a:srgbClr val="2D2D2D"/>
+                </a:solidFill>
+              </a:defRPr>
+            </a:pPr>
+            <a:r>
+              <a:t>  Self-Attn: 94.97% ± 1.66%  |  Prosody: 95.10% ± 2.78%  |  Δ = −0.13pp (n.s.)</a:t>
+            </a:r>
+          </a:p>
+          <a:p>
+            <a:pPr>
+              <a:spcAft>
+                <a:spcPts val="300"/>
+              </a:spcAft>
+              <a:defRPr sz="1100">
+                <a:solidFill>
+                  <a:srgbClr val="2D2D2D"/>
+                </a:solidFill>
+              </a:defRPr>
+            </a:pPr>
+          </a:p>
+          <a:p>
+            <a:pPr>
+              <a:spcAft>
+                <a:spcPts val="300"/>
+              </a:spcAft>
+              <a:defRPr sz="1100">
+                <a:solidFill>
+                  <a:srgbClr val="2D2D2D"/>
+                </a:solidFill>
+              </a:defRPr>
+            </a:pPr>
+            <a:r>
+              <a:t>FAU (4-class, 3-seed):</a:t>
+            </a:r>
+          </a:p>
+          <a:p>
+            <a:pPr>
+              <a:spcAft>
+                <a:spcPts val="300"/>
+              </a:spcAft>
+              <a:defRPr sz="1100">
+                <a:solidFill>
+                  <a:srgbClr val="2D2D2D"/>
+                </a:solidFill>
+              </a:defRPr>
+            </a:pPr>
+            <a:r>
+              <a:t>  Self-Attn: 66.46% ± 0.72%  |  Prosody: 65.15% ± 1.12%  |  Δ = +1.31pp (marginal)</a:t>
+            </a:r>
+          </a:p>
+        </p:txBody>
+      </p:sp>
       <p:sp>
         <p:nvSpPr>
           <p:cNvPr id="6" name="Rectangle 5"/>
@@ -5324,7 +5533,7 @@
               </a:defRPr>
             </a:pPr>
             <a:r>
-              <a:t>关键: Self-Attn最优域内 | Prosody在FAU上Δ仅-1.5pp(近乎持平) | IEMOCAP上Δ高达-10pp(韵律有害) | 零样本C→FAU: 19.56%(分布崩塌)</a:t>
+              <a:t>核心对比: 儿童C-BESD Δ(SA−PG)=−0.13pp (n.s., PG略优) | 成人IEMOCAP Δ=+9.73pp (大幅, PG有害) → 韵律先验方向反转 = 人群依赖性</a:t>
             </a:r>
           </a:p>
         </p:txBody>
@@ -5385,7 +5594,7 @@
               </a:defRPr>
             </a:pPr>
             <a:r>
-              <a:t>05  核心对比：C-BESD vs FAU 池化差异</a:t>
+              <a:t>05  核心对比：三数据集池化差异 (真实多种子)</a:t>
             </a:r>
           </a:p>
         </p:txBody>
@@ -5420,7 +5629,7 @@
               </a:defRPr>
             </a:pPr>
             <a:r>
-              <a:t>儿童自发性语音上Prosody接近Self-Attn — 韵律先验的补偿效应</a:t>
+              <a:t>儿童 vs 成人韵律先验效应方向反转 | C-BESD/FAU: 3-seed | IEMOCAP: 2-seed</a:t>
             </a:r>
           </a:p>
         </p:txBody>
@@ -5514,7 +5723,7 @@
               </a:defRPr>
             </a:pPr>
             <a:r>
-              <a:t>C-BESD (儿童演绎)</a:t>
+              <a:t>C-BESD (儿童演绎, 6cl)</a:t>
             </a:r>
           </a:p>
         </p:txBody>
@@ -5552,7 +5761,7 @@
               </a:defRPr>
             </a:pPr>
             <a:r>
-              <a:t>Self-Attn:  ~93.0%</a:t>
+              <a:t>Self-Attn:  94.97% ± 1.66%</a:t>
             </a:r>
           </a:p>
           <a:p>
@@ -5567,7 +5776,7 @@
               </a:defRPr>
             </a:pPr>
             <a:r>
-              <a:t>Prosody:    ~91.0%  (−2.0pp)</a:t>
+              <a:t>Prosody:    95.10% ± 2.78%</a:t>
             </a:r>
           </a:p>
           <a:p>
@@ -5582,7 +5791,7 @@
               </a:defRPr>
             </a:pPr>
             <a:r>
-              <a:t>Mean:        ~78.0%</a:t>
+              <a:t>Δ = −0.13pp (n.s.)</a:t>
             </a:r>
           </a:p>
         </p:txBody>
@@ -5617,7 +5826,7 @@
               </a:defRPr>
             </a:pPr>
             <a:r>
-              <a:t>FAU Aibo (儿童自发)</a:t>
+              <a:t>FAU Aibo (儿童自发, 4cl)</a:t>
             </a:r>
           </a:p>
         </p:txBody>
@@ -5655,7 +5864,7 @@
               </a:defRPr>
             </a:pPr>
             <a:r>
-              <a:t>Self-Attn:  ~66.5%</a:t>
+              <a:t>Self-Attn:  66.46% ± 0.72%</a:t>
             </a:r>
           </a:p>
           <a:p>
@@ -5670,7 +5879,7 @@
               </a:defRPr>
             </a:pPr>
             <a:r>
-              <a:t>Prosody:    ~65.0%  (−1.5pp)</a:t>
+              <a:t>Prosody:    65.15% ± 1.12%</a:t>
             </a:r>
           </a:p>
           <a:p>
@@ -5685,7 +5894,7 @@
               </a:defRPr>
             </a:pPr>
             <a:r>
-              <a:t>Mean:        ~62.0%</a:t>
+              <a:t>Δ = +1.31pp (marginal)</a:t>
             </a:r>
           </a:p>
         </p:txBody>
@@ -5720,7 +5929,7 @@
               </a:defRPr>
             </a:pPr>
             <a:r>
-              <a:t>IEMOCAP (成人)</a:t>
+              <a:t>IEMOCAP (成人, 4cl)</a:t>
             </a:r>
           </a:p>
         </p:txBody>
@@ -5758,7 +5967,7 @@
               </a:defRPr>
             </a:pPr>
             <a:r>
-              <a:t>Self-Attn:  ~76.0%</a:t>
+              <a:t>Self-Attn:  75.96% ± 7.94%</a:t>
             </a:r>
           </a:p>
           <a:p>
@@ -5773,7 +5982,22 @@
               </a:defRPr>
             </a:pPr>
             <a:r>
-              <a:t>Prosody:    ~66.0%  (−10.0pp!)</a:t>
+              <a:t>Prosody:    66.23% ± 7.56%</a:t>
+            </a:r>
+          </a:p>
+          <a:p>
+            <a:pPr>
+              <a:spcAft>
+                <a:spcPts val="300"/>
+              </a:spcAft>
+              <a:defRPr sz="1000">
+                <a:solidFill>
+                  <a:srgbClr val="2D2D2D"/>
+                </a:solidFill>
+              </a:defRPr>
+            </a:pPr>
+            <a:r>
+              <a:t>Δ = +9.73pp (PG有害!)</a:t>
             </a:r>
           </a:p>
         </p:txBody>
@@ -5825,7 +6049,7 @@
               </a:defRPr>
             </a:pPr>
             <a:r>
-              <a:t>核心发现: 韵律先验的儿童特异性(+2pp) vs 成人有害性(−10pp) — 方向反转 → 儿童SER需要匹配目标人群的声学先验</a:t>
+              <a:t>核心发现: 儿童语音上韵律先验中性(Δ≈0)，成人语音上有害(Δ=+9.73pp) — 方向反转 → 儿童SER无需回避韵律，但也不必依赖</a:t>
             </a:r>
           </a:p>
         </p:txBody>
@@ -5921,7 +6145,7 @@
               </a:defRPr>
             </a:pPr>
             <a:r>
-              <a:t>增强/年龄/风格三维度均成立 | Spearman ρ≈−0.95 [待验证]</a:t>
+              <a:t>增强/年龄/风格/语言四维度均成立 | 所有FD和WA均为真实测量值</a:t>
             </a:r>
           </a:p>
         </p:txBody>
@@ -6418,7 +6642,7 @@
       </p:sp>
       <p:pic>
         <p:nvPicPr>
-          <p:cNvPr id="5" name="Picture 4" descr="fig06_layer_weights.png"/>
+          <p:cNvPr id="5" name="Picture 4" descr="fig06_layer_weights_v2.png"/>
           <p:cNvPicPr>
             <a:picLocks noChangeAspect="1"/>
           </p:cNvPicPr>
@@ -6473,7 +6697,7 @@
               </a:defRPr>
             </a:pPr>
             <a:r>
-              <a:t>关键发现:</a:t>
+              <a:t>实际层权重 (Exp2, epoch=10):</a:t>
             </a:r>
           </a:p>
           <a:p>
@@ -6500,7 +6724,7 @@
               </a:defRPr>
             </a:pPr>
             <a:r>
-              <a:t>• 权熵 ≈ 2.48 (接近均匀)</a:t>
+              <a:t>• Argmax: L9 = 0.0912</a:t>
             </a:r>
           </a:p>
           <a:p>
@@ -6515,7 +6739,7 @@
               </a:defRPr>
             </a:pPr>
             <a:r>
-              <a:t>   → 所有层都有贡献</a:t>
+              <a:t>   (1-based, 0-based=L8)</a:t>
             </a:r>
           </a:p>
           <a:p>
@@ -6542,7 +6766,7 @@
               </a:defRPr>
             </a:pPr>
             <a:r>
-              <a:t>• Argmax: L8-L9 (1-based)</a:t>
+              <a:t>• 最小权重: L4 = 0.0778</a:t>
             </a:r>
           </a:p>
           <a:p>
@@ -6556,9 +6780,6 @@
                 </a:solidFill>
               </a:defRPr>
             </a:pPr>
-            <a:r>
-              <a:t>   → 情绪信息集中于中层</a:t>
-            </a:r>
           </a:p>
           <a:p>
             <a:pPr>
@@ -6571,6 +6792,9 @@
                 </a:solidFill>
               </a:defRPr>
             </a:pPr>
+            <a:r>
+              <a:t>• 非均匀分布:</a:t>
+            </a:r>
           </a:p>
           <a:p>
             <a:pPr>
@@ -6584,7 +6808,7 @@
               </a:defRPr>
             </a:pPr>
             <a:r>
-              <a:t>• 三层数据集一致</a:t>
+              <a:t>   中层(L7-L9) &gt; 低层 &gt; 高层</a:t>
             </a:r>
           </a:p>
           <a:p>
@@ -6599,7 +6823,7 @@
               </a:defRPr>
             </a:pPr>
             <a:r>
-              <a:t>   C-BESD/FAU/IEMOCAP</a:t>
+              <a:t>   L7=0.0876, L8=0.0888</a:t>
             </a:r>
           </a:p>
           <a:p>
@@ -6613,9 +6837,6 @@
                 </a:solidFill>
               </a:defRPr>
             </a:pPr>
-            <a:r>
-              <a:t>   均在此范围内</a:t>
-            </a:r>
           </a:p>
           <a:p>
             <a:pPr>
@@ -6628,6 +6849,9 @@
                 </a:solidFill>
               </a:defRPr>
             </a:pPr>
+            <a:r>
+              <a:t>• 熵 = 2.484</a:t>
+            </a:r>
           </a:p>
           <a:p>
             <a:pPr>
@@ -6641,7 +6865,7 @@
               </a:defRPr>
             </a:pPr>
             <a:r>
-              <a:t>• 层融合: +10pp</a:t>
+              <a:t>   (接近但&lt;均匀值2.485)</a:t>
             </a:r>
           </a:p>
           <a:p>
@@ -6655,8 +6879,35 @@
                 </a:solidFill>
               </a:defRPr>
             </a:pPr>
-            <a:r>
-              <a:t>   (vs 单层最优)</a:t>
+          </a:p>
+          <a:p>
+            <a:pPr>
+              <a:spcAft>
+                <a:spcPts val="300"/>
+              </a:spcAft>
+              <a:defRPr sz="1000">
+                <a:solidFill>
+                  <a:srgbClr val="2D2D2D"/>
+                </a:solidFill>
+              </a:defRPr>
+            </a:pPr>
+            <a:r>
+              <a:t>• 层融合 vs 单层:</a:t>
+            </a:r>
+          </a:p>
+          <a:p>
+            <a:pPr>
+              <a:spcAft>
+                <a:spcPts val="300"/>
+              </a:spcAft>
+              <a:defRPr sz="1000">
+                <a:solidFill>
+                  <a:srgbClr val="2D2D2D"/>
+                </a:solidFill>
+              </a:defRPr>
+            </a:pPr>
+            <a:r>
+              <a:t>   +10pp (ac_suite实测)</a:t>
             </a:r>
           </a:p>
         </p:txBody>

</xml_diff>